<commit_message>
Corregir renderizado de diagramas en presentacion (imagenes PNG + allow-local-files)
</commit_message>
<xml_diff>
--- a/presentacion_erp.pptx
+++ b/presentacion_erp.pptx
@@ -787,7 +787,7 @@
           <a:p>
             <a:r>
               <a:rPr lang="en-US" dirty="0"/>
-              <a:t/>
+              <a:t>fuente: assets/mermaid/06_sectores_erp.mmd</a:t>
             </a:r>
             <a:endParaRPr lang="en-US" dirty="0"/>
           </a:p>
@@ -875,7 +875,7 @@
           <a:p>
             <a:r>
               <a:rPr lang="en-US" dirty="0"/>
-              <a:t/>
+              <a:t>fuente: assets/mermaid/05_tipos_erp.mmd</a:t>
             </a:r>
             <a:endParaRPr lang="en-US" dirty="0"/>
           </a:p>
@@ -1139,7 +1139,7 @@
           <a:p>
             <a:r>
               <a:rPr lang="en-US" dirty="0"/>
-              <a:t/>
+              <a:t>fuente: assets/mermaid/11_seleccion_erp.mmd</a:t>
             </a:r>
             <a:endParaRPr lang="en-US" dirty="0"/>
           </a:p>
@@ -1315,7 +1315,7 @@
           <a:p>
             <a:r>
               <a:rPr lang="en-US" dirty="0"/>
-              <a:t/>
+              <a:t>fuente: assets/mermaid/07_multientidad.mmd</a:t>
             </a:r>
             <a:endParaRPr lang="en-US" dirty="0"/>
           </a:p>
@@ -1403,7 +1403,7 @@
           <a:p>
             <a:r>
               <a:rPr lang="en-US" dirty="0"/>
-              <a:t/>
+              <a:t>fuente: assets/mermaid/08_rbac.mmd</a:t>
             </a:r>
             <a:endParaRPr lang="en-US" dirty="0"/>
           </a:p>
@@ -1931,7 +1931,7 @@
           <a:p>
             <a:r>
               <a:rPr lang="en-US" dirty="0"/>
-              <a:t/>
+              <a:t>fuente: assets/mermaid/01_evolucion_erp.mmd</a:t>
             </a:r>
             <a:endParaRPr lang="en-US" dirty="0"/>
           </a:p>
@@ -2195,7 +2195,7 @@
           <a:p>
             <a:r>
               <a:rPr lang="en-US" dirty="0"/>
-              <a:t/>
+              <a:t>fuente: assets/mermaid/02_arquitectura_erp.mmd</a:t>
             </a:r>
             <a:endParaRPr lang="en-US" dirty="0"/>
           </a:p>
@@ -2283,7 +2283,7 @@
           <a:p>
             <a:r>
               <a:rPr lang="en-US" dirty="0"/>
-              <a:t/>
+              <a:t>fuente: assets/mermaid/13_modulos_horizontal.mmd</a:t>
             </a:r>
             <a:endParaRPr lang="en-US" dirty="0"/>
           </a:p>
@@ -2371,7 +2371,7 @@
           <a:p>
             <a:r>
               <a:rPr lang="en-US" dirty="0"/>
-              <a:t/>
+              <a:t>fuente: assets/mermaid/04_flujo_venta.mmd</a:t>
             </a:r>
             <a:endParaRPr lang="en-US" dirty="0"/>
           </a:p>

</xml_diff>